<commit_message>
Add Baidu Netdisk link for the weight package; links on PPT cover
</commit_message>
<xml_diff>
--- a/reports/wangyuan_vlsot_geo_ppt_5p.pptx
+++ b/reports/wangyuan_vlsot_geo_ppt_5p.pptx
@@ -812,7 +812,7 @@
           <a:lstStyle/>
           <a:p>
             <a:r>
-              <a:t>任务：输入 30 帧单目图像、英文目标描述与相机标定，逐帧输出目标的 l w h x y z（virtuallidar 坐标系）。官方数据包不含标定，我们使用源数据集 V2X-Seq-SPD 路侧端公开的标定文件，只读内参与外参，不读其中任何标注。平台成绩取自方法页 http://vlp.chd.edu.cn/tasks/method/301 的 2026-10-24 16:30 提交；排名取自 2026-10-25 抓取的排行榜，按 SR@0.5 排序第 3（18 个方法中 14 个有成绩）；ACE 在 SR@0.5 大于 0 的 10 个方法中最低。交叉验证为 227 段 TRAIN 按目标 (sequence, track) 分组的 5 折，指标与平台一致（真实 3D IoU、中心欧氏误差）。</a:t>
+              <a:t>任务：输入 30 帧单目图像、英文目标描述与相机标定，逐帧输出目标的 l w h x y z（virtuallidar 坐标系）。数据：TRAIN 227 段 / TEST 10 段，每段 30 帧。代码 https://github.com/Teng10099/VLSOT-2026-Wangyuan-Geo；权重 https://pan.baidu.com/s/1-56d3pIsJE30FOMGDlNdXw?pwd=pgu8（提取码 pgu8）。官方数据包不含标定，我们使用源数据集 V2X-Seq-SPD 路侧端公开的标定文件，只读内参与外参，不读其中任何标注。平台成绩取自方法页 http://vlp.chd.edu.cn/tasks/method/301 的 2026-10-24 16:30 提交；排名取自 2026-10-25 抓取的排行榜，按 SR@0.5 排序第 3（18 个方法中 14 个有成绩）；ACE 在 SR@0.5 大于 0 的 10 个方法中最低。交叉验证为 227 段 TRAIN 按目标 (sequence, track) 分组的 5 折，指标与平台一致（真实 3D IoU、中心欧氏误差）。</a:t>
             </a:r>
           </a:p>
         </p:txBody>
@@ -5007,7 +5007,7 @@
         <p:spPr>
           <a:xfrm>
             <a:off x="548640" y="6419088"/>
-            <a:ext cx="9692640" cy="274320"/>
+            <a:ext cx="9966960" cy="274320"/>
           </a:xfrm>
           <a:prstGeom prst="rect">
             <a:avLst/>
@@ -5051,7 +5051,7 @@
               <a:t>github.com/Teng10099/VLSOT-2026-Wangyuan-Geo（Apache-2.0）</a:t>
             </a:r>
             <a:r>
-              <a:rPr sz="1050" b="0">
+              <a:rPr sz="1050" b="1">
                 <a:solidFill>
                   <a:srgbClr val="52687D"/>
                 </a:solidFill>
@@ -5059,7 +5059,18 @@
                 <a:ea typeface="Microsoft YaHei"/>
                 <a:cs typeface="Microsoft YaHei"/>
               </a:rPr>
-              <a:t>　数据：TRAIN 227 段 / TEST 10 段，每段 30 帧</a:t>
+              <a:t>　权重：</a:t>
+            </a:r>
+            <a:r>
+              <a:rPr sz="1050" b="0">
+                <a:solidFill>
+                  <a:srgbClr val="52687D"/>
+                </a:solidFill>
+                <a:latin typeface="Microsoft YaHei"/>
+                <a:ea typeface="Microsoft YaHei"/>
+                <a:cs typeface="Microsoft YaHei"/>
+              </a:rPr>
+              <a:t>pan.baidu.com/s/1-56d3pIsJE30FOMGDlNdXw（提取码 pgu8）</a:t>
             </a:r>
           </a:p>
         </p:txBody>

</xml_diff>

<commit_message>
Explain the cross-validation vs platform gap (orientation); add analysis/ana_gap.py; update PPT slide 5
</commit_message>
<xml_diff>
--- a/reports/wangyuan_vlsot_geo_ppt_5p.pptx
+++ b/reports/wangyuan_vlsot_geo_ppt_5p.pptx
@@ -1092,7 +1092,7 @@
           <a:lstStyle/>
           <a:p>
             <a:r>
-              <a:t>图为测试集片段的检查图（只用测试图像、文本和我们的预测，不含任何测试标签）。误差上限由 ana_jitter.py 统计（TRAIN 中有三处距离且与 GT 相差 0.3 m 以内的片段）：停车目标看 GT 中心相对片段中位数的偏差；尺寸上限为预测中心等于 GT、尺寸用文本值时的 IoU 分布。平台不提供逐段成绩，因此没有针对单个测试片段调参。</a:t>
+              <a:t>图为测试集片段的检查图（只用测试图像、文本和我们的预测，不含任何测试标签）。差距分析见 vlsot_geo/analysis/ana_gap.py（只用 TRAIN 标签与测试集公开描述）：从 227 段随机抽 10 段，平均 SR@0.5 ≤ 61.67 的概率 0.36%；按测试集情形构成加权预期 87.18，所以难例不能解释差距。误差移植模拟（5000 次）：轴对齐口径预期 SR@0.5 87.0（90% 区间 72.7~96.0）；真值按航向旋转的口径预期 SR@0.5 / SR@0.7 / AOR 为 61.7 / 43.7 / 58.2，平台 61.67 / 38.33 / 57.84；ACE 预期 0.23 m，平台 0.226 m。平台未公开评测代码，以上是推断。误差上限由 ana_jitter.py 统计（TRAIN 中有三处距离且与 GT 相差 0.3 m 以内的片段）：停车目标看 GT 中心相对片段中位数的偏差；尺寸上限为预测中心等于 GT、尺寸用文本值时的 IoU 分布。平台不提供逐段成绩，因此没有针对单个测试片段调参。</a:t>
             </a:r>
           </a:p>
         </p:txBody>
@@ -11013,7 +11013,7 @@
                 <a:ea typeface="Microsoft YaHei"/>
                 <a:cs typeface="Microsoft YaHei"/>
               </a:rPr>
-              <a:t>局限与下一步</a:t>
+              <a:t>CV 88.4 与平台 61.7 的差距：主要在朝向</a:t>
             </a:r>
           </a:p>
           <a:p>
@@ -11034,7 +11034,7 @@
                 <a:ea typeface="Microsoft YaHei"/>
                 <a:cs typeface="Microsoft YaHei"/>
               </a:rPr>
-              <a:t>· 测试集难例集中：两个左下角截断的近处目标（约 15 m）、两个约 100 m 远的运动目标</a:t>
+              <a:t>· 提交格式没有朝向。测试集 3 段斜向行驶（航向 77°、-79°、-146°），若按真值朝向算 IoU，定位完全正确时上限也只有 0.31 / 0.24 / 0.46</a:t>
             </a:r>
           </a:p>
           <a:p>
@@ -11055,7 +11055,7 @@
                 <a:ea typeface="Microsoft YaHei"/>
                 <a:cs typeface="Microsoft YaHei"/>
               </a:rPr>
-              <a:t>· CV 88.4 与平台 61.7 的差距推测主要来自这些难例（近处截断片段在 TRAIN 中只有 19 / 227 段）；平台不给逐段成绩，无法逐段核实</a:t>
+              <a:t>· 其余 7 段 210 帧中 185 帧达标（88.1%），与 CV 一致；误差移植模拟：轴对齐预期 87，按真值朝向预期 61.7</a:t>
             </a:r>
           </a:p>
           <a:p>
@@ -11076,7 +11076,7 @@
                 <a:ea typeface="Microsoft YaHei"/>
                 <a:cs typeface="Microsoft YaHei"/>
               </a:rPr>
-              <a:t>· 计划：检测框测试时增强精修框边、远处目标亚像素定位、整段轨迹联合优化</a:t>
+              <a:t>· 下一步：输出与朝向匹配的框；截断框边精修、远处目标亚像素定位</a:t>
             </a:r>
           </a:p>
         </p:txBody>

</xml_diff>